<commit_message>
Revalidación del 11-10-2026 con GLM-5.3-Flash y el modelo gratuito de opencode
- validacion.json: 38 de 38 con GLM (F.3 y EJ 21 en modo interactivo; F.0 y F.1 como programas) y 33 de 33 de los
  ejercicios con encargo también con el modelo gratuito (big-pickle). Notas nuevas de lo que pasó en los que cambiaron.
- Soluciones reales regeneradas (incluidas F.3 y EJ 21 en interactivo), anonimizadas.
- Enunciados y soluciones dicen también el resultado con el modelo gratuito.
- Presentación y PDF con los datos nuevos; README con validación y coste al día.
- Wiki de modelos: el límite de uso es por modelo y qué hacer si se agota.
</commit_message>
<xml_diff>
--- a/alumnos/soluciones/ej11_informe_pptx/ficheros/presentacion.pptx
+++ b/alumnos/soluciones/ej11_informe_pptx/ficheros/presentacion.pptx
@@ -3100,8 +3100,8 @@
         </p:nvSpPr>
         <p:spPr>
           <a:xfrm>
-            <a:off x="914400" y="2103120"/>
-            <a:ext cx="10332720" cy="914400"/>
+            <a:off x="914400" y="2286000"/>
+            <a:ext cx="10332720" cy="2743200"/>
           </a:xfrm>
           <a:prstGeom prst="rect">
             <a:avLst/>
@@ -3109,51 +3109,40 @@
           <a:noFill/>
         </p:spPr>
         <p:txBody>
-          <a:bodyPr wrap="square">
+          <a:bodyPr wrap="none">
             <a:spAutoFit/>
           </a:bodyPr>
           <a:lstStyle/>
           <a:p>
-            <a:r>
-              <a:rPr sz="4400" b="1">
+            <a:pPr>
+              <a:defRPr sz="5400" b="1"/>
+            </a:pPr>
+            <a:r>
+              <a:t>Informe de cosecha</a:t>
+            </a:r>
+          </a:p>
+          <a:p>
+            <a:pPr>
+              <a:defRPr sz="2800">
                 <a:solidFill>
-                  <a:srgbClr val="6B1F2F"/>
+                  <a:srgbClr val="595959"/>
                 </a:solidFill>
-              </a:rPr>
-              <a:t>Bodega Larraz</a:t>
-            </a:r>
-          </a:p>
-        </p:txBody>
-      </p:sp>
-      <p:sp>
-        <p:nvSpPr>
-          <p:cNvPr id="3" name="TextBox 2"/>
-          <p:cNvSpPr txBox="1"/>
-          <p:nvPr/>
-        </p:nvSpPr>
-        <p:spPr>
-          <a:xfrm>
-            <a:off x="914400" y="3108960"/>
-            <a:ext cx="10332720" cy="731520"/>
-          </a:xfrm>
-          <a:prstGeom prst="rect">
-            <a:avLst/>
-          </a:prstGeom>
-          <a:noFill/>
-        </p:spPr>
-        <p:txBody>
-          <a:bodyPr wrap="square">
-            <a:spAutoFit/>
-          </a:bodyPr>
-          <a:lstStyle/>
-          <a:p>
-            <a:r>
-              <a:rPr sz="2400" b="0">
+              </a:defRPr>
+            </a:pPr>
+            <a:r>
+              <a:t>Bodega Larraz — Vendimia 2025</a:t>
+            </a:r>
+          </a:p>
+          <a:p>
+            <a:pPr>
+              <a:defRPr sz="1600">
                 <a:solidFill>
-                  <a:srgbClr val="333333"/>
+                  <a:srgbClr val="595959"/>
                 </a:solidFill>
-              </a:rPr>
-              <a:t>Informe de cosecha — Vendimia 2025</a:t>
+              </a:defRPr>
+            </a:pPr>
+            <a:r>
+              <a:t>Asamblea de la cooperativa · Datos de la vendimia 2025</a:t>
             </a:r>
           </a:p>
         </p:txBody>
@@ -3184,8 +3173,45 @@
         </p:nvSpPr>
         <p:spPr>
           <a:xfrm>
-            <a:off x="731520" y="548640"/>
-            <a:ext cx="10698480" cy="822960"/>
+            <a:off x="0" y="0"/>
+            <a:ext cx="12191695" cy="1097280"/>
+          </a:xfrm>
+          <a:prstGeom prst="rect">
+            <a:avLst/>
+          </a:prstGeom>
+          <a:solidFill>
+            <a:srgbClr val="7A1F1F"/>
+          </a:solidFill>
+        </p:spPr>
+        <p:txBody>
+          <a:bodyPr wrap="none">
+            <a:spAutoFit/>
+          </a:bodyPr>
+          <a:lstStyle/>
+          <a:p>
+            <a:pPr>
+              <a:defRPr sz="3000" b="1">
+                <a:solidFill>
+                  <a:srgbClr val="FFFFFF"/>
+                </a:solidFill>
+              </a:defRPr>
+            </a:pPr>
+            <a:r>
+              <a:t>Resumen</a:t>
+            </a:r>
+          </a:p>
+        </p:txBody>
+      </p:sp>
+      <p:sp>
+        <p:nvSpPr>
+          <p:cNvPr id="3" name="TextBox 2"/>
+          <p:cNvSpPr txBox="1"/>
+          <p:nvPr/>
+        </p:nvSpPr>
+        <p:spPr>
+          <a:xfrm>
+            <a:off x="914400" y="1645920"/>
+            <a:ext cx="10332720" cy="4389120"/>
           </a:xfrm>
           <a:prstGeom prst="rect">
             <a:avLst/>
@@ -3193,81 +3219,24 @@
           <a:noFill/>
         </p:spPr>
         <p:txBody>
-          <a:bodyPr wrap="square">
+          <a:bodyPr wrap="none">
             <a:spAutoFit/>
           </a:bodyPr>
           <a:lstStyle/>
           <a:p>
-            <a:r>
-              <a:rPr sz="3000" b="1">
-                <a:solidFill>
-                  <a:srgbClr val="6B1F2F"/>
-                </a:solidFill>
-              </a:rPr>
-              <a:t>Resumen de la vendimia 2025</a:t>
-            </a:r>
-          </a:p>
-        </p:txBody>
-      </p:sp>
-      <p:sp>
-        <p:nvSpPr>
-          <p:cNvPr id="3" name="TextBox 2"/>
-          <p:cNvSpPr txBox="1"/>
-          <p:nvPr/>
-        </p:nvSpPr>
-        <p:spPr>
-          <a:xfrm>
-            <a:off x="731520" y="1737360"/>
-            <a:ext cx="10698480" cy="3200400"/>
-          </a:xfrm>
-          <a:prstGeom prst="rect">
-            <a:avLst/>
-          </a:prstGeom>
-          <a:noFill/>
-        </p:spPr>
-        <p:txBody>
-          <a:bodyPr wrap="square">
-            <a:spAutoFit/>
-          </a:bodyPr>
-          <a:lstStyle/>
-          <a:p>
-            <a:r>
-              <a:rPr sz="2000" b="0">
-                <a:solidFill>
-                  <a:srgbClr val="333333"/>
-                </a:solidFill>
-              </a:rPr>
-              <a:t>• La vendimia de 2025 cerró con 84.000 kg de uva recogida.</a:t>
-            </a:r>
-          </a:p>
-          <a:p>
-            <a:r>
-              <a:rPr sz="2000" b="0">
-                <a:solidFill>
-                  <a:srgbClr val="333333"/>
-                </a:solidFill>
-              </a:rPr>
-              <a:t>• Un 12 % menos que en 2024 (95.500 kg) por la sequía del verano.</a:t>
-            </a:r>
-          </a:p>
-          <a:p>
-            <a:r>
-              <a:rPr sz="2000" b="0">
-                <a:solidFill>
-                  <a:srgbClr val="333333"/>
-                </a:solidFill>
-              </a:rPr>
-              <a:t>• La calidad fue excelente: la graduación media subió de</a:t>
-            </a:r>
-          </a:p>
-          <a:p>
-            <a:r>
-              <a:rPr sz="2000" b="0">
-                <a:solidFill>
-                  <a:srgbClr val="333333"/>
-                </a:solidFill>
-              </a:rPr>
-              <a:t>   12,1 a 13,4 grados Baumé.</a:t>
+            <a:pPr>
+              <a:defRPr sz="2400"/>
+            </a:pPr>
+            <a:r>
+              <a:t>La vendimia de 2025 cerró con 84.000 kg de uva recogida, un 12% menos que en 2024 (95.500 kg) por la sequía del verano.</a:t>
+            </a:r>
+          </a:p>
+          <a:p>
+            <a:pPr>
+              <a:defRPr sz="2400"/>
+            </a:pPr>
+            <a:r>
+              <a:t>Aun así, la calidad fue excelente: la graduación media subió de 12,1 a 13,4 grados Baumé.</a:t>
             </a:r>
           </a:p>
         </p:txBody>
@@ -3298,8 +3267,45 @@
         </p:nvSpPr>
         <p:spPr>
           <a:xfrm>
-            <a:off x="731520" y="548640"/>
-            <a:ext cx="10698480" cy="822960"/>
+            <a:off x="0" y="0"/>
+            <a:ext cx="12191695" cy="1097280"/>
+          </a:xfrm>
+          <a:prstGeom prst="rect">
+            <a:avLst/>
+          </a:prstGeom>
+          <a:solidFill>
+            <a:srgbClr val="7A1F1F"/>
+          </a:solidFill>
+        </p:spPr>
+        <p:txBody>
+          <a:bodyPr wrap="none">
+            <a:spAutoFit/>
+          </a:bodyPr>
+          <a:lstStyle/>
+          <a:p>
+            <a:pPr>
+              <a:defRPr sz="3000" b="1">
+                <a:solidFill>
+                  <a:srgbClr val="FFFFFF"/>
+                </a:solidFill>
+              </a:defRPr>
+            </a:pPr>
+            <a:r>
+              <a:t>Rendimiento por variedad</a:t>
+            </a:r>
+          </a:p>
+        </p:txBody>
+      </p:sp>
+      <p:sp>
+        <p:nvSpPr>
+          <p:cNvPr id="3" name="TextBox 2"/>
+          <p:cNvSpPr txBox="1"/>
+          <p:nvPr/>
+        </p:nvSpPr>
+        <p:spPr>
+          <a:xfrm>
+            <a:off x="914400" y="1645920"/>
+            <a:ext cx="10332720" cy="4572000"/>
           </a:xfrm>
           <a:prstGeom prst="rect">
             <a:avLst/>
@@ -3307,33 +3313,24 @@
           <a:noFill/>
         </p:spPr>
         <p:txBody>
-          <a:bodyPr wrap="square">
+          <a:bodyPr wrap="none">
             <a:spAutoFit/>
           </a:bodyPr>
           <a:lstStyle/>
-          <a:p>
-            <a:r>
-              <a:rPr sz="3000" b="1">
-                <a:solidFill>
-                  <a:srgbClr val="6B1F2F"/>
-                </a:solidFill>
-              </a:rPr>
-              <a:t>Rendimiento por variedad</a:t>
-            </a:r>
-          </a:p>
+          <a:p/>
         </p:txBody>
       </p:sp>
       <p:graphicFrame>
         <p:nvGraphicFramePr>
-          <p:cNvPr id="3" name="Table 2"/>
+          <p:cNvPr id="4" name="Table 3"/>
           <p:cNvGraphicFramePr>
             <a:graphicFrameLocks noGrp="1"/>
           </p:cNvGraphicFramePr>
           <p:nvPr/>
         </p:nvGraphicFramePr>
         <p:xfrm>
-          <a:off x="731520" y="1737360"/>
-          <a:ext cx="10698480" cy="3474720"/>
+          <a:off x="914400" y="1645920"/>
+          <a:ext cx="10332720" cy="3657600"/>
         </p:xfrm>
         <a:graphic>
           <a:graphicData uri="http://schemas.openxmlformats.org/drawingml/2006/table">
@@ -3342,23 +3339,19 @@
                 <a:tableStyleId>{5C22544A-7EE6-4342-B048-85BDC9FD1C3A}</a:tableStyleId>
               </a:tblPr>
               <a:tblGrid>
-                <a:gridCol w="3200400"/>
-                <a:gridCol w="2377440"/>
-                <a:gridCol w="2011680"/>
-                <a:gridCol w="3108960"/>
+                <a:gridCol w="2583180"/>
+                <a:gridCol w="2583180"/>
+                <a:gridCol w="2583180"/>
+                <a:gridCol w="2583180"/>
               </a:tblGrid>
-              <a:tr h="694944">
+              <a:tr h="731520">
                 <a:tc>
                   <a:txBody>
                     <a:bodyPr/>
                     <a:lstStyle/>
                     <a:p>
                       <a:r>
-                        <a:rPr sz="1600" b="1">
-                          <a:solidFill>
-                            <a:srgbClr val="6B1F2F"/>
-                          </a:solidFill>
-                        </a:rPr>
+                        <a:rPr b="1" sz="2000"/>
                         <a:t>Variedad</a:t>
                       </a:r>
                     </a:p>
@@ -3371,12 +3364,8 @@
                     <a:lstStyle/>
                     <a:p>
                       <a:r>
-                        <a:rPr sz="1600" b="1">
-                          <a:solidFill>
-                            <a:srgbClr val="6B1F2F"/>
-                          </a:solidFill>
-                        </a:rPr>
-                        <a:t>Kg recogidos</a:t>
+                        <a:rPr b="1" sz="2000"/>
+                        <a:t>Kg</a:t>
                       </a:r>
                     </a:p>
                   </a:txBody>
@@ -3388,11 +3377,7 @@
                     <a:lstStyle/>
                     <a:p>
                       <a:r>
-                        <a:rPr sz="1600" b="1">
-                          <a:solidFill>
-                            <a:srgbClr val="6B1F2F"/>
-                          </a:solidFill>
-                        </a:rPr>
+                        <a:rPr b="1" sz="2000"/>
                         <a:t>% del total</a:t>
                       </a:r>
                     </a:p>
@@ -3405,11 +3390,7 @@
                     <a:lstStyle/>
                     <a:p>
                       <a:r>
-                        <a:rPr sz="1600" b="1">
-                          <a:solidFill>
-                            <a:srgbClr val="6B1F2F"/>
-                          </a:solidFill>
-                        </a:rPr>
+                        <a:rPr b="1" sz="2000"/>
                         <a:t>Graduación (Baumé)</a:t>
                       </a:r>
                     </a:p>
@@ -3417,14 +3398,14 @@
                   <a:tcPr/>
                 </a:tc>
               </a:tr>
-              <a:tr h="694944">
+              <a:tr h="731520">
                 <a:tc>
                   <a:txBody>
                     <a:bodyPr/>
                     <a:lstStyle/>
                     <a:p>
                       <a:r>
-                        <a:rPr sz="1600" b="0"/>
+                        <a:rPr sz="2000"/>
                         <a:t>Garnacha</a:t>
                       </a:r>
                     </a:p>
@@ -3437,8 +3418,8 @@
                     <a:lstStyle/>
                     <a:p>
                       <a:r>
-                        <a:rPr sz="1600" b="0"/>
-                        <a:t>41.000 kg</a:t>
+                        <a:rPr sz="2000"/>
+                        <a:t>41.000</a:t>
                       </a:r>
                     </a:p>
                   </a:txBody>
@@ -3450,8 +3431,8 @@
                     <a:lstStyle/>
                     <a:p>
                       <a:r>
-                        <a:rPr sz="1600" b="0"/>
-                        <a:t>49 %</a:t>
+                        <a:rPr sz="2000"/>
+                        <a:t>49%</a:t>
                       </a:r>
                     </a:p>
                   </a:txBody>
@@ -3463,7 +3444,7 @@
                     <a:lstStyle/>
                     <a:p>
                       <a:r>
-                        <a:rPr sz="1600" b="0"/>
+                        <a:rPr sz="2000"/>
                         <a:t>13,8</a:t>
                       </a:r>
                     </a:p>
@@ -3471,14 +3452,14 @@
                   <a:tcPr/>
                 </a:tc>
               </a:tr>
-              <a:tr h="694944">
+              <a:tr h="731520">
                 <a:tc>
                   <a:txBody>
                     <a:bodyPr/>
                     <a:lstStyle/>
                     <a:p>
                       <a:r>
-                        <a:rPr sz="1600" b="0"/>
+                        <a:rPr sz="2000"/>
                         <a:t>Tempranillo</a:t>
                       </a:r>
                     </a:p>
@@ -3491,8 +3472,8 @@
                     <a:lstStyle/>
                     <a:p>
                       <a:r>
-                        <a:rPr sz="1600" b="0"/>
-                        <a:t>28.500 kg</a:t>
+                        <a:rPr sz="2000"/>
+                        <a:t>28.500</a:t>
                       </a:r>
                     </a:p>
                   </a:txBody>
@@ -3504,8 +3485,8 @@
                     <a:lstStyle/>
                     <a:p>
                       <a:r>
-                        <a:rPr sz="1600" b="0"/>
-                        <a:t>34 %</a:t>
+                        <a:rPr sz="2000"/>
+                        <a:t>34%</a:t>
                       </a:r>
                     </a:p>
                   </a:txBody>
@@ -3517,7 +3498,7 @@
                     <a:lstStyle/>
                     <a:p>
                       <a:r>
-                        <a:rPr sz="1600" b="0"/>
+                        <a:rPr sz="2000"/>
                         <a:t>13,1</a:t>
                       </a:r>
                     </a:p>
@@ -3525,14 +3506,14 @@
                   <a:tcPr/>
                 </a:tc>
               </a:tr>
-              <a:tr h="694944">
+              <a:tr h="731520">
                 <a:tc>
                   <a:txBody>
                     <a:bodyPr/>
                     <a:lstStyle/>
                     <a:p>
                       <a:r>
-                        <a:rPr sz="1600" b="0"/>
+                        <a:rPr sz="2000"/>
                         <a:t>Graciano</a:t>
                       </a:r>
                     </a:p>
@@ -3545,8 +3526,8 @@
                     <a:lstStyle/>
                     <a:p>
                       <a:r>
-                        <a:rPr sz="1600" b="0"/>
-                        <a:t>9.500 kg</a:t>
+                        <a:rPr sz="2000"/>
+                        <a:t>9.500</a:t>
                       </a:r>
                     </a:p>
                   </a:txBody>
@@ -3558,8 +3539,8 @@
                     <a:lstStyle/>
                     <a:p>
                       <a:r>
-                        <a:rPr sz="1600" b="0"/>
-                        <a:t>11 %</a:t>
+                        <a:rPr sz="2000"/>
+                        <a:t>11%</a:t>
                       </a:r>
                     </a:p>
                   </a:txBody>
@@ -3571,7 +3552,7 @@
                     <a:lstStyle/>
                     <a:p>
                       <a:r>
-                        <a:rPr sz="1600" b="0"/>
+                        <a:rPr sz="2000"/>
                         <a:t>13,0</a:t>
                       </a:r>
                     </a:p>
@@ -3579,14 +3560,14 @@
                   <a:tcPr/>
                 </a:tc>
               </a:tr>
-              <a:tr h="694944">
+              <a:tr h="731520">
                 <a:tc>
                   <a:txBody>
                     <a:bodyPr/>
                     <a:lstStyle/>
                     <a:p>
                       <a:r>
-                        <a:rPr sz="1600" b="0"/>
+                        <a:rPr sz="2000"/>
                         <a:t>Otras variedades</a:t>
                       </a:r>
                     </a:p>
@@ -3599,8 +3580,8 @@
                     <a:lstStyle/>
                     <a:p>
                       <a:r>
-                        <a:rPr sz="1600" b="0"/>
-                        <a:t>5.000 kg</a:t>
+                        <a:rPr sz="2000"/>
+                        <a:t>5.000</a:t>
                       </a:r>
                     </a:p>
                   </a:txBody>
@@ -3612,8 +3593,8 @@
                     <a:lstStyle/>
                     <a:p>
                       <a:r>
-                        <a:rPr sz="1600" b="0"/>
-                        <a:t>6 %</a:t>
+                        <a:rPr sz="2000"/>
+                        <a:t>6%</a:t>
                       </a:r>
                     </a:p>
                   </a:txBody>
@@ -3625,7 +3606,7 @@
                     <a:lstStyle/>
                     <a:p>
                       <a:r>
-                        <a:rPr sz="1600" b="0"/>
+                        <a:rPr sz="2000"/>
                         <a:t>12,6</a:t>
                       </a:r>
                     </a:p>
@@ -3663,8 +3644,45 @@
         </p:nvSpPr>
         <p:spPr>
           <a:xfrm>
-            <a:off x="731520" y="548640"/>
-            <a:ext cx="10698480" cy="822960"/>
+            <a:off x="0" y="0"/>
+            <a:ext cx="12191695" cy="1097280"/>
+          </a:xfrm>
+          <a:prstGeom prst="rect">
+            <a:avLst/>
+          </a:prstGeom>
+          <a:solidFill>
+            <a:srgbClr val="7A1F1F"/>
+          </a:solidFill>
+        </p:spPr>
+        <p:txBody>
+          <a:bodyPr wrap="none">
+            <a:spAutoFit/>
+          </a:bodyPr>
+          <a:lstStyle/>
+          <a:p>
+            <a:pPr>
+              <a:defRPr sz="3000" b="1">
+                <a:solidFill>
+                  <a:srgbClr val="FFFFFF"/>
+                </a:solidFill>
+              </a:defRPr>
+            </a:pPr>
+            <a:r>
+              <a:t>Evolución (kg totales)</a:t>
+            </a:r>
+          </a:p>
+        </p:txBody>
+      </p:sp>
+      <p:sp>
+        <p:nvSpPr>
+          <p:cNvPr id="3" name="TextBox 2"/>
+          <p:cNvSpPr txBox="1"/>
+          <p:nvPr/>
+        </p:nvSpPr>
+        <p:spPr>
+          <a:xfrm>
+            <a:off x="731520" y="2011680"/>
+            <a:ext cx="1920240" cy="548640"/>
           </a:xfrm>
           <a:prstGeom prst="rect">
             <a:avLst/>
@@ -3672,32 +3690,30 @@
           <a:noFill/>
         </p:spPr>
         <p:txBody>
-          <a:bodyPr wrap="square">
+          <a:bodyPr wrap="none">
             <a:spAutoFit/>
           </a:bodyPr>
           <a:lstStyle/>
           <a:p>
-            <a:r>
-              <a:rPr sz="3000" b="1">
-                <a:solidFill>
-                  <a:srgbClr val="6B1F2F"/>
-                </a:solidFill>
-              </a:rPr>
-              <a:t>Evolución (kg totales)</a:t>
-            </a:r>
-          </a:p>
-        </p:txBody>
-      </p:sp>
-      <p:sp>
-        <p:nvSpPr>
-          <p:cNvPr id="3" name="TextBox 2"/>
+            <a:pPr>
+              <a:defRPr sz="2400" b="1"/>
+            </a:pPr>
+            <a:r>
+              <a:t>2021</a:t>
+            </a:r>
+          </a:p>
+        </p:txBody>
+      </p:sp>
+      <p:sp>
+        <p:nvSpPr>
+          <p:cNvPr id="4" name="TextBox 3"/>
           <p:cNvSpPr txBox="1"/>
           <p:nvPr/>
         </p:nvSpPr>
         <p:spPr>
           <a:xfrm>
-            <a:off x="822960" y="2011680"/>
-            <a:ext cx="1828800" cy="548640"/>
+            <a:off x="731520" y="2651760"/>
+            <a:ext cx="1920240" cy="731520"/>
           </a:xfrm>
           <a:prstGeom prst="rect">
             <a:avLst/>
@@ -3705,32 +3721,34 @@
           <a:noFill/>
         </p:spPr>
         <p:txBody>
-          <a:bodyPr wrap="square">
+          <a:bodyPr wrap="none">
             <a:spAutoFit/>
           </a:bodyPr>
           <a:lstStyle/>
           <a:p>
-            <a:r>
-              <a:rPr sz="1800" b="1">
+            <a:pPr>
+              <a:defRPr sz="2200">
                 <a:solidFill>
-                  <a:srgbClr val="6B1F2F"/>
+                  <a:srgbClr val="595959"/>
                 </a:solidFill>
-              </a:rPr>
-              <a:t>2021</a:t>
-            </a:r>
-          </a:p>
-        </p:txBody>
-      </p:sp>
-      <p:sp>
-        <p:nvSpPr>
-          <p:cNvPr id="4" name="TextBox 3"/>
+              </a:defRPr>
+            </a:pPr>
+            <a:r>
+              <a:t>71.000 kg</a:t>
+            </a:r>
+          </a:p>
+        </p:txBody>
+      </p:sp>
+      <p:sp>
+        <p:nvSpPr>
+          <p:cNvPr id="5" name="TextBox 4"/>
           <p:cNvSpPr txBox="1"/>
           <p:nvPr/>
         </p:nvSpPr>
         <p:spPr>
           <a:xfrm>
-            <a:off x="822960" y="2743200"/>
-            <a:ext cx="1828800" cy="548640"/>
+            <a:off x="3017520" y="2011680"/>
+            <a:ext cx="1920240" cy="548640"/>
           </a:xfrm>
           <a:prstGeom prst="rect">
             <a:avLst/>
@@ -3738,32 +3756,30 @@
           <a:noFill/>
         </p:spPr>
         <p:txBody>
-          <a:bodyPr wrap="square">
+          <a:bodyPr wrap="none">
             <a:spAutoFit/>
           </a:bodyPr>
           <a:lstStyle/>
           <a:p>
-            <a:r>
-              <a:rPr sz="2200" b="0">
-                <a:solidFill>
-                  <a:srgbClr val="333333"/>
-                </a:solidFill>
-              </a:rPr>
-              <a:t>71.000 kg</a:t>
-            </a:r>
-          </a:p>
-        </p:txBody>
-      </p:sp>
-      <p:sp>
-        <p:nvSpPr>
-          <p:cNvPr id="5" name="TextBox 4"/>
+            <a:pPr>
+              <a:defRPr sz="2400" b="1"/>
+            </a:pPr>
+            <a:r>
+              <a:t>2022</a:t>
+            </a:r>
+          </a:p>
+        </p:txBody>
+      </p:sp>
+      <p:sp>
+        <p:nvSpPr>
+          <p:cNvPr id="6" name="TextBox 5"/>
           <p:cNvSpPr txBox="1"/>
           <p:nvPr/>
         </p:nvSpPr>
         <p:spPr>
           <a:xfrm>
-            <a:off x="3017520" y="2011680"/>
-            <a:ext cx="1828800" cy="548640"/>
+            <a:off x="3017520" y="2651760"/>
+            <a:ext cx="1920240" cy="731520"/>
           </a:xfrm>
           <a:prstGeom prst="rect">
             <a:avLst/>
@@ -3771,32 +3787,34 @@
           <a:noFill/>
         </p:spPr>
         <p:txBody>
-          <a:bodyPr wrap="square">
+          <a:bodyPr wrap="none">
             <a:spAutoFit/>
           </a:bodyPr>
           <a:lstStyle/>
           <a:p>
-            <a:r>
-              <a:rPr sz="1800" b="1">
+            <a:pPr>
+              <a:defRPr sz="2200">
                 <a:solidFill>
-                  <a:srgbClr val="6B1F2F"/>
+                  <a:srgbClr val="595959"/>
                 </a:solidFill>
-              </a:rPr>
-              <a:t>2022</a:t>
-            </a:r>
-          </a:p>
-        </p:txBody>
-      </p:sp>
-      <p:sp>
-        <p:nvSpPr>
-          <p:cNvPr id="6" name="TextBox 5"/>
+              </a:defRPr>
+            </a:pPr>
+            <a:r>
+              <a:t>79.500 kg</a:t>
+            </a:r>
+          </a:p>
+        </p:txBody>
+      </p:sp>
+      <p:sp>
+        <p:nvSpPr>
+          <p:cNvPr id="7" name="TextBox 6"/>
           <p:cNvSpPr txBox="1"/>
           <p:nvPr/>
         </p:nvSpPr>
         <p:spPr>
           <a:xfrm>
-            <a:off x="3017520" y="2743200"/>
-            <a:ext cx="1828800" cy="548640"/>
+            <a:off x="5303520" y="2011680"/>
+            <a:ext cx="1920240" cy="548640"/>
           </a:xfrm>
           <a:prstGeom prst="rect">
             <a:avLst/>
@@ -3804,32 +3822,30 @@
           <a:noFill/>
         </p:spPr>
         <p:txBody>
-          <a:bodyPr wrap="square">
+          <a:bodyPr wrap="none">
             <a:spAutoFit/>
           </a:bodyPr>
           <a:lstStyle/>
           <a:p>
-            <a:r>
-              <a:rPr sz="2200" b="0">
-                <a:solidFill>
-                  <a:srgbClr val="333333"/>
-                </a:solidFill>
-              </a:rPr>
-              <a:t>79.500 kg</a:t>
-            </a:r>
-          </a:p>
-        </p:txBody>
-      </p:sp>
-      <p:sp>
-        <p:nvSpPr>
-          <p:cNvPr id="7" name="TextBox 6"/>
+            <a:pPr>
+              <a:defRPr sz="2400" b="1"/>
+            </a:pPr>
+            <a:r>
+              <a:t>2023</a:t>
+            </a:r>
+          </a:p>
+        </p:txBody>
+      </p:sp>
+      <p:sp>
+        <p:nvSpPr>
+          <p:cNvPr id="8" name="TextBox 7"/>
           <p:cNvSpPr txBox="1"/>
           <p:nvPr/>
         </p:nvSpPr>
         <p:spPr>
           <a:xfrm>
-            <a:off x="5212080" y="2011680"/>
-            <a:ext cx="1828800" cy="548640"/>
+            <a:off x="5303520" y="2651760"/>
+            <a:ext cx="1920240" cy="731520"/>
           </a:xfrm>
           <a:prstGeom prst="rect">
             <a:avLst/>
@@ -3837,32 +3853,34 @@
           <a:noFill/>
         </p:spPr>
         <p:txBody>
-          <a:bodyPr wrap="square">
+          <a:bodyPr wrap="none">
             <a:spAutoFit/>
           </a:bodyPr>
           <a:lstStyle/>
           <a:p>
-            <a:r>
-              <a:rPr sz="1800" b="1">
+            <a:pPr>
+              <a:defRPr sz="2200">
                 <a:solidFill>
-                  <a:srgbClr val="6B1F2F"/>
+                  <a:srgbClr val="595959"/>
                 </a:solidFill>
-              </a:rPr>
-              <a:t>2023</a:t>
-            </a:r>
-          </a:p>
-        </p:txBody>
-      </p:sp>
-      <p:sp>
-        <p:nvSpPr>
-          <p:cNvPr id="8" name="TextBox 7"/>
+              </a:defRPr>
+            </a:pPr>
+            <a:r>
+              <a:t>88.000 kg</a:t>
+            </a:r>
+          </a:p>
+        </p:txBody>
+      </p:sp>
+      <p:sp>
+        <p:nvSpPr>
+          <p:cNvPr id="9" name="TextBox 8"/>
           <p:cNvSpPr txBox="1"/>
           <p:nvPr/>
         </p:nvSpPr>
         <p:spPr>
           <a:xfrm>
-            <a:off x="5212080" y="2743200"/>
-            <a:ext cx="1828800" cy="548640"/>
+            <a:off x="7589520" y="2011680"/>
+            <a:ext cx="1920240" cy="548640"/>
           </a:xfrm>
           <a:prstGeom prst="rect">
             <a:avLst/>
@@ -3870,32 +3888,30 @@
           <a:noFill/>
         </p:spPr>
         <p:txBody>
-          <a:bodyPr wrap="square">
+          <a:bodyPr wrap="none">
             <a:spAutoFit/>
           </a:bodyPr>
           <a:lstStyle/>
           <a:p>
-            <a:r>
-              <a:rPr sz="2200" b="0">
-                <a:solidFill>
-                  <a:srgbClr val="333333"/>
-                </a:solidFill>
-              </a:rPr>
-              <a:t>88.000 kg</a:t>
-            </a:r>
-          </a:p>
-        </p:txBody>
-      </p:sp>
-      <p:sp>
-        <p:nvSpPr>
-          <p:cNvPr id="9" name="TextBox 8"/>
+            <a:pPr>
+              <a:defRPr sz="2400" b="1"/>
+            </a:pPr>
+            <a:r>
+              <a:t>2024</a:t>
+            </a:r>
+          </a:p>
+        </p:txBody>
+      </p:sp>
+      <p:sp>
+        <p:nvSpPr>
+          <p:cNvPr id="10" name="TextBox 9"/>
           <p:cNvSpPr txBox="1"/>
           <p:nvPr/>
         </p:nvSpPr>
         <p:spPr>
           <a:xfrm>
-            <a:off x="7406640" y="2011680"/>
-            <a:ext cx="1828800" cy="548640"/>
+            <a:off x="7589520" y="2651760"/>
+            <a:ext cx="1920240" cy="731520"/>
           </a:xfrm>
           <a:prstGeom prst="rect">
             <a:avLst/>
@@ -3903,32 +3919,34 @@
           <a:noFill/>
         </p:spPr>
         <p:txBody>
-          <a:bodyPr wrap="square">
+          <a:bodyPr wrap="none">
             <a:spAutoFit/>
           </a:bodyPr>
           <a:lstStyle/>
           <a:p>
-            <a:r>
-              <a:rPr sz="1800" b="1">
+            <a:pPr>
+              <a:defRPr sz="2200">
                 <a:solidFill>
-                  <a:srgbClr val="6B1F2F"/>
+                  <a:srgbClr val="595959"/>
                 </a:solidFill>
-              </a:rPr>
-              <a:t>2024</a:t>
-            </a:r>
-          </a:p>
-        </p:txBody>
-      </p:sp>
-      <p:sp>
-        <p:nvSpPr>
-          <p:cNvPr id="10" name="TextBox 9"/>
+              </a:defRPr>
+            </a:pPr>
+            <a:r>
+              <a:t>95.500 kg</a:t>
+            </a:r>
+          </a:p>
+        </p:txBody>
+      </p:sp>
+      <p:sp>
+        <p:nvSpPr>
+          <p:cNvPr id="11" name="TextBox 10"/>
           <p:cNvSpPr txBox="1"/>
           <p:nvPr/>
         </p:nvSpPr>
         <p:spPr>
           <a:xfrm>
-            <a:off x="7406640" y="2743200"/>
-            <a:ext cx="1828800" cy="548640"/>
+            <a:off x="9875520" y="2011680"/>
+            <a:ext cx="1920240" cy="548640"/>
           </a:xfrm>
           <a:prstGeom prst="rect">
             <a:avLst/>
@@ -3936,32 +3954,30 @@
           <a:noFill/>
         </p:spPr>
         <p:txBody>
-          <a:bodyPr wrap="square">
+          <a:bodyPr wrap="none">
             <a:spAutoFit/>
           </a:bodyPr>
           <a:lstStyle/>
           <a:p>
-            <a:r>
-              <a:rPr sz="2200" b="0">
-                <a:solidFill>
-                  <a:srgbClr val="333333"/>
-                </a:solidFill>
-              </a:rPr>
-              <a:t>95.500 kg</a:t>
-            </a:r>
-          </a:p>
-        </p:txBody>
-      </p:sp>
-      <p:sp>
-        <p:nvSpPr>
-          <p:cNvPr id="11" name="TextBox 10"/>
+            <a:pPr>
+              <a:defRPr sz="2400" b="1"/>
+            </a:pPr>
+            <a:r>
+              <a:t>2025</a:t>
+            </a:r>
+          </a:p>
+        </p:txBody>
+      </p:sp>
+      <p:sp>
+        <p:nvSpPr>
+          <p:cNvPr id="12" name="TextBox 11"/>
           <p:cNvSpPr txBox="1"/>
           <p:nvPr/>
         </p:nvSpPr>
         <p:spPr>
           <a:xfrm>
-            <a:off x="9601200" y="2011680"/>
-            <a:ext cx="1828800" cy="548640"/>
+            <a:off x="9875520" y="2651760"/>
+            <a:ext cx="1920240" cy="731520"/>
           </a:xfrm>
           <a:prstGeom prst="rect">
             <a:avLst/>
@@ -3969,32 +3985,34 @@
           <a:noFill/>
         </p:spPr>
         <p:txBody>
-          <a:bodyPr wrap="square">
+          <a:bodyPr wrap="none">
             <a:spAutoFit/>
           </a:bodyPr>
           <a:lstStyle/>
           <a:p>
-            <a:r>
-              <a:rPr sz="1800" b="1">
+            <a:pPr>
+              <a:defRPr sz="2200">
                 <a:solidFill>
-                  <a:srgbClr val="6B1F2F"/>
+                  <a:srgbClr val="595959"/>
                 </a:solidFill>
-              </a:rPr>
-              <a:t>2025</a:t>
-            </a:r>
-          </a:p>
-        </p:txBody>
-      </p:sp>
-      <p:sp>
-        <p:nvSpPr>
-          <p:cNvPr id="12" name="TextBox 11"/>
+              </a:defRPr>
+            </a:pPr>
+            <a:r>
+              <a:t>84.000 kg</a:t>
+            </a:r>
+          </a:p>
+        </p:txBody>
+      </p:sp>
+      <p:sp>
+        <p:nvSpPr>
+          <p:cNvPr id="13" name="TextBox 12"/>
           <p:cNvSpPr txBox="1"/>
           <p:nvPr/>
         </p:nvSpPr>
         <p:spPr>
           <a:xfrm>
-            <a:off x="9601200" y="2743200"/>
-            <a:ext cx="1828800" cy="548640"/>
+            <a:off x="914400" y="5120640"/>
+            <a:ext cx="10332720" cy="914400"/>
           </a:xfrm>
           <a:prstGeom prst="rect">
             <a:avLst/>
@@ -4002,18 +4020,16 @@
           <a:noFill/>
         </p:spPr>
         <p:txBody>
-          <a:bodyPr wrap="square">
+          <a:bodyPr wrap="none">
             <a:spAutoFit/>
           </a:bodyPr>
           <a:lstStyle/>
           <a:p>
-            <a:r>
-              <a:rPr sz="2200" b="0">
-                <a:solidFill>
-                  <a:srgbClr val="333333"/>
-                </a:solidFill>
-              </a:rPr>
-              <a:t>84.000 kg</a:t>
+            <a:pPr>
+              <a:defRPr sz="1800" i="1"/>
+            </a:pPr>
+            <a:r>
+              <a:t>Máximo en 2024 (95.500 kg); retroceso del 12% en 2025 por la sequía.</a:t>
             </a:r>
           </a:p>
         </p:txBody>
@@ -4044,8 +4060,45 @@
         </p:nvSpPr>
         <p:spPr>
           <a:xfrm>
-            <a:off x="731520" y="548640"/>
-            <a:ext cx="10698480" cy="822960"/>
+            <a:off x="0" y="0"/>
+            <a:ext cx="12191695" cy="1097280"/>
+          </a:xfrm>
+          <a:prstGeom prst="rect">
+            <a:avLst/>
+          </a:prstGeom>
+          <a:solidFill>
+            <a:srgbClr val="7A1F1F"/>
+          </a:solidFill>
+        </p:spPr>
+        <p:txBody>
+          <a:bodyPr wrap="none">
+            <a:spAutoFit/>
+          </a:bodyPr>
+          <a:lstStyle/>
+          <a:p>
+            <a:pPr>
+              <a:defRPr sz="3000" b="1">
+                <a:solidFill>
+                  <a:srgbClr val="FFFFFF"/>
+                </a:solidFill>
+              </a:defRPr>
+            </a:pPr>
+            <a:r>
+              <a:t>Conclusiones</a:t>
+            </a:r>
+          </a:p>
+        </p:txBody>
+      </p:sp>
+      <p:sp>
+        <p:nvSpPr>
+          <p:cNvPr id="3" name="TextBox 2"/>
+          <p:cNvSpPr txBox="1"/>
+          <p:nvPr/>
+        </p:nvSpPr>
+        <p:spPr>
+          <a:xfrm>
+            <a:off x="914400" y="1645920"/>
+            <a:ext cx="10332720" cy="4114800"/>
           </a:xfrm>
           <a:prstGeom prst="rect">
             <a:avLst/>
@@ -4053,71 +4106,24 @@
           <a:noFill/>
         </p:spPr>
         <p:txBody>
-          <a:bodyPr wrap="square">
+          <a:bodyPr wrap="none">
             <a:spAutoFit/>
           </a:bodyPr>
           <a:lstStyle/>
           <a:p>
-            <a:r>
-              <a:rPr sz="3000" b="1">
-                <a:solidFill>
-                  <a:srgbClr val="6B1F2F"/>
-                </a:solidFill>
-              </a:rPr>
-              <a:t>Conclusiones</a:t>
-            </a:r>
-          </a:p>
-        </p:txBody>
-      </p:sp>
-      <p:sp>
-        <p:nvSpPr>
-          <p:cNvPr id="3" name="TextBox 2"/>
-          <p:cNvSpPr txBox="1"/>
-          <p:nvPr/>
-        </p:nvSpPr>
-        <p:spPr>
-          <a:xfrm>
-            <a:off x="731520" y="1737360"/>
-            <a:ext cx="10698480" cy="2743200"/>
-          </a:xfrm>
-          <a:prstGeom prst="rect">
-            <a:avLst/>
-          </a:prstGeom>
-          <a:noFill/>
-        </p:spPr>
-        <p:txBody>
-          <a:bodyPr wrap="square">
-            <a:spAutoFit/>
-          </a:bodyPr>
-          <a:lstStyle/>
-          <a:p>
-            <a:r>
-              <a:rPr sz="2000" b="0">
-                <a:solidFill>
-                  <a:srgbClr val="333333"/>
-                </a:solidFill>
-              </a:rPr>
-              <a:t>• Menos cantidad pero más grado: se prevé un vino estructurado</a:t>
-            </a:r>
-          </a:p>
-          <a:p>
-            <a:r>
-              <a:rPr sz="2000" b="0">
-                <a:solidFill>
-                  <a:srgbClr val="333333"/>
-                </a:solidFill>
-              </a:rPr>
-              <a:t>   con mayor potencial de crianza.</a:t>
-            </a:r>
-          </a:p>
-          <a:p>
-            <a:r>
-              <a:rPr sz="2000" b="0">
-                <a:solidFill>
-                  <a:srgbClr val="333333"/>
-                </a:solidFill>
-              </a:rPr>
-              <a:t>• Se recomienda ampliar la parcela de Garnacha en 2026.</a:t>
+            <a:pPr>
+              <a:defRPr sz="2400"/>
+            </a:pPr>
+            <a:r>
+              <a:t>Menos cantidad pero más grado: se prevé un vino estructurado con mayor potencial de crianza.</a:t>
+            </a:r>
+          </a:p>
+          <a:p>
+            <a:pPr>
+              <a:defRPr sz="2400"/>
+            </a:pPr>
+            <a:r>
+              <a:t>Se recomienda ampliar la parcela de Garnacha en 2026.</a:t>
             </a:r>
           </a:p>
         </p:txBody>

</xml_diff>